<commit_message>
nicer current divider rule
</commit_message>
<xml_diff>
--- a/slides/2_DCcircuits.pptx
+++ b/slides/2_DCcircuits.pptx
@@ -228,7 +228,7 @@
           <a:p>
             <a:fld id="{50F0DBE5-119B-9546-A717-70798062973B}" type="datetimeFigureOut">
               <a:rPr lang="de-DE" smtClean="0"/>
-              <a:t>15.11.25</a:t>
+              <a:t>21.10.26</a:t>
             </a:fld>
             <a:endParaRPr lang="de-DE"/>
           </a:p>
@@ -642,7 +642,7 @@
           <a:p>
             <a:fld id="{CE5B6352-3465-4344-964A-B25153893676}" type="datetime1">
               <a:rPr lang="de-DE" smtClean="0"/>
-              <a:t>15.11.25</a:t>
+              <a:t>21.10.26</a:t>
             </a:fld>
             <a:endParaRPr lang="de-DE"/>
           </a:p>
@@ -840,7 +840,7 @@
           <a:p>
             <a:fld id="{680476C1-F079-0F40-9C5B-039EA12ABDAA}" type="datetime1">
               <a:rPr lang="de-DE" smtClean="0"/>
-              <a:t>15.11.25</a:t>
+              <a:t>21.10.26</a:t>
             </a:fld>
             <a:endParaRPr lang="de-DE"/>
           </a:p>
@@ -1048,7 +1048,7 @@
           <a:p>
             <a:fld id="{95A166F0-C736-5846-BD29-206B3FE0CE89}" type="datetime1">
               <a:rPr lang="de-DE" smtClean="0"/>
-              <a:t>15.11.25</a:t>
+              <a:t>21.10.26</a:t>
             </a:fld>
             <a:endParaRPr lang="de-DE"/>
           </a:p>
@@ -1246,7 +1246,7 @@
           <a:p>
             <a:fld id="{C501BE91-62CD-C14F-A910-7294FC82D4A0}" type="datetime1">
               <a:rPr lang="de-DE" smtClean="0"/>
-              <a:t>15.11.25</a:t>
+              <a:t>21.10.26</a:t>
             </a:fld>
             <a:endParaRPr lang="de-DE"/>
           </a:p>
@@ -1521,7 +1521,7 @@
           <a:p>
             <a:fld id="{BF974C23-8003-8246-BE47-B5ECC9F69FCF}" type="datetime1">
               <a:rPr lang="de-DE" smtClean="0"/>
-              <a:t>15.11.25</a:t>
+              <a:t>21.10.26</a:t>
             </a:fld>
             <a:endParaRPr lang="de-DE"/>
           </a:p>
@@ -1786,7 +1786,7 @@
           <a:p>
             <a:fld id="{9399C134-D3BA-F044-A1BA-5D8F00C16B33}" type="datetime1">
               <a:rPr lang="de-DE" smtClean="0"/>
-              <a:t>15.11.25</a:t>
+              <a:t>21.10.26</a:t>
             </a:fld>
             <a:endParaRPr lang="de-DE"/>
           </a:p>
@@ -2198,7 +2198,7 @@
           <a:p>
             <a:fld id="{CAA0E14A-B13F-B84D-BA0A-4382E133E05F}" type="datetime1">
               <a:rPr lang="de-DE" smtClean="0"/>
-              <a:t>15.11.25</a:t>
+              <a:t>21.10.26</a:t>
             </a:fld>
             <a:endParaRPr lang="de-DE"/>
           </a:p>
@@ -2339,7 +2339,7 @@
           <a:p>
             <a:fld id="{82499081-64A1-E641-A060-B3FE5E7414AE}" type="datetime1">
               <a:rPr lang="de-DE" smtClean="0"/>
-              <a:t>15.11.25</a:t>
+              <a:t>21.10.26</a:t>
             </a:fld>
             <a:endParaRPr lang="de-DE"/>
           </a:p>
@@ -2452,7 +2452,7 @@
           <a:p>
             <a:fld id="{72507737-E8BF-5348-A8D5-F635D39F9B4A}" type="datetime1">
               <a:rPr lang="de-DE" smtClean="0"/>
-              <a:t>15.11.25</a:t>
+              <a:t>21.10.26</a:t>
             </a:fld>
             <a:endParaRPr lang="de-DE"/>
           </a:p>
@@ -2763,7 +2763,7 @@
           <a:p>
             <a:fld id="{E5AF2D44-8DB2-1E42-B969-A879F4E80DE2}" type="datetime1">
               <a:rPr lang="de-DE" smtClean="0"/>
-              <a:t>15.11.25</a:t>
+              <a:t>21.10.26</a:t>
             </a:fld>
             <a:endParaRPr lang="de-DE"/>
           </a:p>
@@ -3051,7 +3051,7 @@
           <a:p>
             <a:fld id="{BDCC8AD7-B1B1-5742-9D45-5FF116011C65}" type="datetime1">
               <a:rPr lang="de-DE" smtClean="0"/>
-              <a:t>15.11.25</a:t>
+              <a:t>21.10.26</a:t>
             </a:fld>
             <a:endParaRPr lang="de-DE"/>
           </a:p>
@@ -3292,7 +3292,7 @@
           <a:p>
             <a:fld id="{108D9C44-3672-2C4D-8D64-277C579E81B1}" type="datetime1">
               <a:rPr lang="de-DE" smtClean="0"/>
-              <a:t>15.11.25</a:t>
+              <a:t>21.10.26</a:t>
             </a:fld>
             <a:endParaRPr lang="de-DE"/>
           </a:p>
@@ -3778,10 +3778,10 @@
           <p:nvPr/>
         </p:nvPicPr>
         <p:blipFill>
-          <a:blip r:embed="rId2">
+          <a:blip>
             <a:extLst>
               <a:ext uri="{96DAC541-7B7A-43D3-8B79-37D633B846F1}">
-                <asvg:svgBlip xmlns:asvg="http://schemas.microsoft.com/office/drawing/2016/SVG/main" r:embed="rId3"/>
+                <asvg:svgBlip xmlns:asvg="http://schemas.microsoft.com/office/drawing/2016/SVG/main" r:embed="rId2"/>
               </a:ext>
             </a:extLst>
           </a:blip>
@@ -3814,10 +3814,10 @@
           <p:nvPr/>
         </p:nvPicPr>
         <p:blipFill>
-          <a:blip r:embed="rId4">
+          <a:blip>
             <a:extLst>
               <a:ext uri="{96DAC541-7B7A-43D3-8B79-37D633B846F1}">
-                <asvg:svgBlip xmlns:asvg="http://schemas.microsoft.com/office/drawing/2016/SVG/main" r:embed="rId5"/>
+                <asvg:svgBlip xmlns:asvg="http://schemas.microsoft.com/office/drawing/2016/SVG/main" r:embed="rId3"/>
               </a:ext>
             </a:extLst>
           </a:blip>
@@ -3850,10 +3850,10 @@
           <p:nvPr/>
         </p:nvPicPr>
         <p:blipFill>
-          <a:blip r:embed="rId6">
+          <a:blip>
             <a:extLst>
               <a:ext uri="{96DAC541-7B7A-43D3-8B79-37D633B846F1}">
-                <asvg:svgBlip xmlns:asvg="http://schemas.microsoft.com/office/drawing/2016/SVG/main" r:embed="rId7"/>
+                <asvg:svgBlip xmlns:asvg="http://schemas.microsoft.com/office/drawing/2016/SVG/main" r:embed="rId4"/>
               </a:ext>
             </a:extLst>
           </a:blip>
@@ -3886,10 +3886,10 @@
           <p:nvPr/>
         </p:nvPicPr>
         <p:blipFill>
-          <a:blip r:embed="rId8">
+          <a:blip>
             <a:extLst>
               <a:ext uri="{96DAC541-7B7A-43D3-8B79-37D633B846F1}">
-                <asvg:svgBlip xmlns:asvg="http://schemas.microsoft.com/office/drawing/2016/SVG/main" r:embed="rId9"/>
+                <asvg:svgBlip xmlns:asvg="http://schemas.microsoft.com/office/drawing/2016/SVG/main" r:embed="rId5"/>
               </a:ext>
             </a:extLst>
           </a:blip>
@@ -3922,7 +3922,7 @@
           <p:nvPr/>
         </p:nvPicPr>
         <p:blipFill>
-          <a:blip r:embed="rId10"/>
+          <a:blip r:embed="rId6"/>
           <a:stretch>
             <a:fillRect/>
           </a:stretch>
@@ -4179,13 +4179,13 @@
                     <m:oMathParaPr>
                       <m:jc m:val="left"/>
                     </m:oMathParaPr>
-                    <m:oMath xmlns:m="http://schemas.openxmlformats.org/officeDocument/2006/math">
+                    <m:oMath>
                       <m:nary>
                         <m:naryPr>
                           <m:chr m:val="∑"/>
                           <m:limLoc m:val="undOvr"/>
                           <m:ctrlPr>
-                            <a:rPr lang="de-DE" i="1">
+                            <a:rPr lang="de-DE" b="0" i="1" smtClean="0">
                               <a:latin typeface="Cambria Math" panose="02040503050406030204" pitchFamily="18" charset="0"/>
                             </a:rPr>
                           </m:ctrlPr>
@@ -4404,11 +4404,11 @@
                     <m:oMathParaPr>
                       <m:jc m:val="left"/>
                     </m:oMathParaPr>
-                    <m:oMath xmlns:m="http://schemas.openxmlformats.org/officeDocument/2006/math">
+                    <m:oMath>
                       <m:sSub>
                         <m:sSubPr>
                           <m:ctrlPr>
-                            <a:rPr lang="de-DE" sz="2400" i="1" smtClean="0">
+                            <a:rPr lang="de-DE" sz="2400" b="0" i="1" smtClean="0">
                               <a:latin typeface="Cambria Math" panose="02040503050406030204" pitchFamily="18" charset="0"/>
                             </a:rPr>
                           </m:ctrlPr>
@@ -4825,13 +4825,13 @@
                     <m:oMathParaPr>
                       <m:jc m:val="left"/>
                     </m:oMathParaPr>
-                    <m:oMath xmlns:m="http://schemas.openxmlformats.org/officeDocument/2006/math">
+                    <m:oMath>
                       <m:nary>
                         <m:naryPr>
                           <m:chr m:val="∑"/>
                           <m:limLoc m:val="undOvr"/>
                           <m:ctrlPr>
-                            <a:rPr lang="de-DE" i="1">
+                            <a:rPr lang="de-DE" b="0" i="1" smtClean="0">
                               <a:latin typeface="Cambria Math" panose="02040503050406030204" pitchFamily="18" charset="0"/>
                             </a:rPr>
                           </m:ctrlPr>
@@ -4865,7 +4865,7 @@
                           <m:sSub>
                             <m:sSubPr>
                               <m:ctrlPr>
-                                <a:rPr lang="de-DE" i="1">
+                                <a:rPr lang="de-DE" b="0" i="1" smtClean="0">
                                   <a:latin typeface="Cambria Math" panose="02040503050406030204" pitchFamily="18" charset="0"/>
                                 </a:rPr>
                               </m:ctrlPr>
@@ -4993,10 +4993,10 @@
           <p:nvPr/>
         </p:nvPicPr>
         <p:blipFill>
-          <a:blip r:embed="rId3">
+          <a:blip>
             <a:extLst>
               <a:ext uri="{96DAC541-7B7A-43D3-8B79-37D633B846F1}">
-                <asvg:svgBlip xmlns:asvg="http://schemas.microsoft.com/office/drawing/2016/SVG/main" r:embed="rId4"/>
+                <asvg:svgBlip xmlns:asvg="http://schemas.microsoft.com/office/drawing/2016/SVG/main" r:embed="rId3"/>
               </a:ext>
             </a:extLst>
           </a:blip>
@@ -5050,11 +5050,11 @@
                     <m:oMathParaPr>
                       <m:jc m:val="left"/>
                     </m:oMathParaPr>
-                    <m:oMath xmlns:m="http://schemas.openxmlformats.org/officeDocument/2006/math">
+                    <m:oMath>
                       <m:sSub>
                         <m:sSubPr>
                           <m:ctrlPr>
-                            <a:rPr lang="de-DE" sz="2400" i="1" smtClean="0">
+                            <a:rPr lang="de-DE" sz="2400" i="1">
                               <a:latin typeface="Cambria Math" panose="02040503050406030204" pitchFamily="18" charset="0"/>
                             </a:rPr>
                           </m:ctrlPr>
@@ -5085,7 +5085,7 @@
                       <m:sSub>
                         <m:sSubPr>
                           <m:ctrlPr>
-                            <a:rPr lang="de-DE" sz="2400" i="1" smtClean="0">
+                            <a:rPr lang="de-DE" sz="2400" b="0" i="1" smtClean="0">
                               <a:latin typeface="Cambria Math" panose="02040503050406030204" pitchFamily="18" charset="0"/>
                             </a:rPr>
                           </m:ctrlPr>
@@ -5116,7 +5116,7 @@
                       <m:sSub>
                         <m:sSubPr>
                           <m:ctrlPr>
-                            <a:rPr lang="de-DE" sz="2400" i="1">
+                            <a:rPr lang="de-DE" sz="2400" b="0" i="1" smtClean="0">
                               <a:latin typeface="Cambria Math" panose="02040503050406030204" pitchFamily="18" charset="0"/>
                             </a:rPr>
                           </m:ctrlPr>
@@ -5147,7 +5147,7 @@
                       <m:sSub>
                         <m:sSubPr>
                           <m:ctrlPr>
-                            <a:rPr lang="de-DE" sz="2400" i="1">
+                            <a:rPr lang="de-DE" sz="2400" b="0" i="1" smtClean="0">
                               <a:latin typeface="Cambria Math" panose="02040503050406030204" pitchFamily="18" charset="0"/>
                             </a:rPr>
                           </m:ctrlPr>
@@ -5433,7 +5433,7 @@
                         <m:sSub>
                           <m:sSubPr>
                             <m:ctrlPr>
-                              <a:rPr lang="de-DE" sz="2600" i="1">
+                              <a:rPr lang="de-DE" sz="2600" b="0" i="1" smtClean="0">
                                 <a:latin typeface="Cambria Math" panose="02040503050406030204" pitchFamily="18" charset="0"/>
                               </a:rPr>
                             </m:ctrlPr>
@@ -5464,7 +5464,7 @@
                         <m:sSub>
                           <m:sSubPr>
                             <m:ctrlPr>
-                              <a:rPr lang="de-DE" sz="2600" i="1">
+                              <a:rPr lang="de-DE" sz="2600" b="0" i="1" smtClean="0">
                                 <a:latin typeface="Cambria Math" panose="02040503050406030204" pitchFamily="18" charset="0"/>
                               </a:rPr>
                             </m:ctrlPr>
@@ -5495,7 +5495,7 @@
                         <m:sSub>
                           <m:sSubPr>
                             <m:ctrlPr>
-                              <a:rPr lang="de-DE" sz="2600" i="1">
+                              <a:rPr lang="de-DE" sz="2600" b="0" i="1" smtClean="0">
                                 <a:latin typeface="Cambria Math" panose="02040503050406030204" pitchFamily="18" charset="0"/>
                               </a:rPr>
                             </m:ctrlPr>
@@ -5736,10 +5736,10 @@
           <p:nvPr/>
         </p:nvPicPr>
         <p:blipFill>
-          <a:blip r:embed="rId3">
+          <a:blip>
             <a:extLst>
               <a:ext uri="{96DAC541-7B7A-43D3-8B79-37D633B846F1}">
-                <asvg:svgBlip xmlns:asvg="http://schemas.microsoft.com/office/drawing/2016/SVG/main" r:embed="rId4"/>
+                <asvg:svgBlip xmlns:asvg="http://schemas.microsoft.com/office/drawing/2016/SVG/main" r:embed="rId3"/>
               </a:ext>
             </a:extLst>
           </a:blip>
@@ -5772,10 +5772,10 @@
           <p:nvPr/>
         </p:nvPicPr>
         <p:blipFill>
-          <a:blip r:embed="rId5">
+          <a:blip>
             <a:extLst>
               <a:ext uri="{96DAC541-7B7A-43D3-8B79-37D633B846F1}">
-                <asvg:svgBlip xmlns:asvg="http://schemas.microsoft.com/office/drawing/2016/SVG/main" r:embed="rId6"/>
+                <asvg:svgBlip xmlns:asvg="http://schemas.microsoft.com/office/drawing/2016/SVG/main" r:embed="rId4"/>
               </a:ext>
             </a:extLst>
           </a:blip>
@@ -5826,10 +5826,7 @@
                 <a:pPr/>
                 <a14:m>
                   <m:oMathPara xmlns:m="http://schemas.openxmlformats.org/officeDocument/2006/math">
-                    <m:oMathParaPr>
-                      <m:jc m:val="centerGroup"/>
-                    </m:oMathParaPr>
-                    <m:oMath xmlns:m="http://schemas.openxmlformats.org/officeDocument/2006/math">
+                    <m:oMath>
                       <m:r>
                         <a:rPr lang="de-DE" sz="2800" b="0" i="1" smtClean="0">
                           <a:latin typeface="Cambria Math" panose="02040503050406030204" pitchFamily="18" charset="0"/>
@@ -5878,7 +5875,7 @@
                           <m:sSub>
                             <m:sSubPr>
                               <m:ctrlPr>
-                                <a:rPr lang="de-DE" sz="2800" i="1">
+                                <a:rPr lang="de-DE" sz="2800" b="0" i="1" smtClean="0">
                                   <a:latin typeface="Cambria Math" panose="02040503050406030204" pitchFamily="18" charset="0"/>
                                 </a:rPr>
                               </m:ctrlPr>
@@ -6010,7 +6007,7 @@
                     <m:sSub>
                       <m:sSubPr>
                         <m:ctrlPr>
-                          <a:rPr lang="de-DE" sz="2800" i="1" smtClean="0">
+                          <a:rPr lang="de-DE" sz="2800" b="0" i="1" smtClean="0">
                             <a:latin typeface="Cambria Math" panose="02040503050406030204" pitchFamily="18" charset="0"/>
                           </a:rPr>
                         </m:ctrlPr>
@@ -6127,7 +6124,7 @@
                         <m:sSub>
                           <m:sSubPr>
                             <m:ctrlPr>
-                              <a:rPr lang="de-DE" sz="2800" i="1">
+                              <a:rPr lang="de-DE" sz="2800" b="0" i="1" smtClean="0">
                                 <a:latin typeface="Cambria Math" panose="02040503050406030204" pitchFamily="18" charset="0"/>
                               </a:rPr>
                             </m:ctrlPr>
@@ -6154,7 +6151,7 @@
                         <m:sSub>
                           <m:sSubPr>
                             <m:ctrlPr>
-                              <a:rPr lang="de-DE" sz="2800" i="1">
+                              <a:rPr lang="de-DE" sz="2800" b="0" i="1" smtClean="0">
                                 <a:latin typeface="Cambria Math" panose="02040503050406030204" pitchFamily="18" charset="0"/>
                               </a:rPr>
                             </m:ctrlPr>
@@ -7130,10 +7127,7 @@
                 <a:pPr/>
                 <a14:m>
                   <m:oMathPara xmlns:m="http://schemas.openxmlformats.org/officeDocument/2006/math">
-                    <m:oMathParaPr>
-                      <m:jc m:val="centerGroup"/>
-                    </m:oMathParaPr>
-                    <m:oMath xmlns:m="http://schemas.openxmlformats.org/officeDocument/2006/math">
+                    <m:oMath>
                       <m:r>
                         <a:rPr lang="de-DE" sz="2800" b="0" i="1" smtClean="0">
                           <a:latin typeface="Cambria Math" panose="02040503050406030204" pitchFamily="18" charset="0"/>
@@ -7149,7 +7143,7 @@
                       <m:sSup>
                         <m:sSupPr>
                           <m:ctrlPr>
-                            <a:rPr lang="de-DE" sz="2800" i="1" smtClean="0">
+                            <a:rPr lang="de-DE" sz="2800" i="1">
                               <a:latin typeface="Cambria Math" panose="02040503050406030204" pitchFamily="18" charset="0"/>
                             </a:rPr>
                           </m:ctrlPr>
@@ -7323,10 +7317,10 @@
           <p:nvPr/>
         </p:nvPicPr>
         <p:blipFill>
-          <a:blip r:embed="rId4">
+          <a:blip>
             <a:extLst>
               <a:ext uri="{96DAC541-7B7A-43D3-8B79-37D633B846F1}">
-                <asvg:svgBlip xmlns:asvg="http://schemas.microsoft.com/office/drawing/2016/SVG/main" r:embed="rId5"/>
+                <asvg:svgBlip xmlns:asvg="http://schemas.microsoft.com/office/drawing/2016/SVG/main" r:embed="rId4"/>
               </a:ext>
             </a:extLst>
           </a:blip>
@@ -7377,10 +7371,7 @@
                 <a:pPr/>
                 <a14:m>
                   <m:oMathPara xmlns:m="http://schemas.openxmlformats.org/officeDocument/2006/math">
-                    <m:oMathParaPr>
-                      <m:jc m:val="centerGroup"/>
-                    </m:oMathParaPr>
-                    <m:oMath xmlns:m="http://schemas.openxmlformats.org/officeDocument/2006/math">
+                    <m:oMath>
                       <m:r>
                         <a:rPr lang="de-DE" sz="2800" b="0" i="1" smtClean="0">
                           <a:latin typeface="Cambria Math" panose="02040503050406030204" pitchFamily="18" charset="0"/>
@@ -7429,7 +7420,7 @@
                           <m:sSub>
                             <m:sSubPr>
                               <m:ctrlPr>
-                                <a:rPr lang="de-DE" sz="2800" i="1">
+                                <a:rPr lang="de-DE" sz="2800" b="0" i="1" smtClean="0">
                                   <a:latin typeface="Cambria Math" panose="02040503050406030204" pitchFamily="18" charset="0"/>
                                 </a:rPr>
                               </m:ctrlPr>
@@ -7506,8 +7497,8 @@
           </p:sp>
         </mc:Fallback>
       </mc:AlternateContent>
-      <mc:AlternateContent xmlns:mc="http://schemas.openxmlformats.org/markup-compatibility/2006" xmlns:a14="http://schemas.microsoft.com/office/drawing/2010/main">
-        <mc:Choice Requires="a14">
+      <mc:AlternateContent xmlns:mc="http://schemas.openxmlformats.org/markup-compatibility/2006">
+        <mc:Choice xmlns:a14="http://schemas.microsoft.com/office/drawing/2010/main" Requires="a14">
           <p:sp>
             <p:nvSpPr>
               <p:cNvPr id="6" name="Textfeld 5">
@@ -7523,7 +7514,7 @@
             <p:spPr>
               <a:xfrm>
                 <a:off x="838201" y="5465002"/>
-                <a:ext cx="10515599" cy="1310359"/>
+                <a:ext cx="10515599" cy="1342996"/>
               </a:xfrm>
               <a:prstGeom prst="rect">
                 <a:avLst/>
@@ -7561,7 +7552,7 @@
                     <m:sSub>
                       <m:sSubPr>
                         <m:ctrlPr>
-                          <a:rPr lang="de-DE" sz="2800" i="1" smtClean="0">
+                          <a:rPr lang="de-DE" sz="2800" b="0" i="1" smtClean="0">
                             <a:latin typeface="Cambria Math" panose="02040503050406030204" pitchFamily="18" charset="0"/>
                           </a:rPr>
                         </m:ctrlPr>
@@ -7604,6 +7595,14 @@
                         </m:ctrlPr>
                       </m:fPr>
                       <m:num>
+                        <m:r>
+                          <a:rPr lang="de-DE" sz="2800" b="0" i="1" smtClean="0">
+                            <a:latin typeface="Cambria Math" panose="02040503050406030204" pitchFamily="18" charset="0"/>
+                          </a:rPr>
+                          <m:t>𝑅</m:t>
+                        </m:r>
+                      </m:num>
+                      <m:den>
                         <m:sSub>
                           <m:sSubPr>
                             <m:ctrlPr>
@@ -7617,7 +7616,7 @@
                               <a:rPr lang="de-DE" sz="2800" b="0" i="1" smtClean="0">
                                 <a:latin typeface="Cambria Math" panose="02040503050406030204" pitchFamily="18" charset="0"/>
                               </a:rPr>
-                              <m:t>𝐺</m:t>
+                              <m:t>𝑅</m:t>
                             </m:r>
                           </m:e>
                           <m:sub>
@@ -7629,14 +7628,6 @@
                             </m:r>
                           </m:sub>
                         </m:sSub>
-                      </m:num>
-                      <m:den>
-                        <m:r>
-                          <a:rPr lang="de-DE" sz="2800" b="0" i="1" smtClean="0">
-                            <a:latin typeface="Cambria Math" panose="02040503050406030204" pitchFamily="18" charset="0"/>
-                          </a:rPr>
-                          <m:t>𝐺</m:t>
-                        </m:r>
                       </m:den>
                     </m:f>
                   </m:oMath>
@@ -7678,7 +7669,7 @@
                         <m:sSub>
                           <m:sSubPr>
                             <m:ctrlPr>
-                              <a:rPr lang="de-DE" sz="2800" i="1">
+                              <a:rPr lang="de-DE" sz="2800" b="0" i="1" smtClean="0">
                                 <a:latin typeface="Cambria Math" panose="02040503050406030204" pitchFamily="18" charset="0"/>
                               </a:rPr>
                             </m:ctrlPr>
@@ -7705,7 +7696,7 @@
                         <m:sSub>
                           <m:sSubPr>
                             <m:ctrlPr>
-                              <a:rPr lang="de-DE" sz="2800" i="1">
+                              <a:rPr lang="de-DE" sz="2800" b="0" i="1" smtClean="0">
                                 <a:latin typeface="Cambria Math" panose="02040503050406030204" pitchFamily="18" charset="0"/>
                               </a:rPr>
                             </m:ctrlPr>
@@ -8085,7 +8076,7 @@
             </p:txBody>
           </p:sp>
         </mc:Choice>
-        <mc:Fallback xmlns="">
+        <mc:Fallback>
           <p:sp>
             <p:nvSpPr>
               <p:cNvPr id="6" name="Textfeld 5">
@@ -8103,7 +8094,7 @@
             <p:spPr>
               <a:xfrm>
                 <a:off x="838201" y="5465002"/>
-                <a:ext cx="10515599" cy="1310359"/>
+                <a:ext cx="10515599" cy="1342996"/>
               </a:xfrm>
               <a:prstGeom prst="rect">
                 <a:avLst/>
@@ -8111,7 +8102,7 @@
               <a:blipFill>
                 <a:blip r:embed="rId7"/>
                 <a:stretch>
-                  <a:fillRect l="-2171" t="-962" b="-2885"/>
+                  <a:fillRect l="-2171" t="-1869" b="-3738"/>
                 </a:stretch>
               </a:blipFill>
             </p:spPr>
@@ -8972,10 +8963,10 @@
           <p:nvPr/>
         </p:nvPicPr>
         <p:blipFill>
-          <a:blip r:embed="rId2">
+          <a:blip>
             <a:extLst>
               <a:ext uri="{96DAC541-7B7A-43D3-8B79-37D633B846F1}">
-                <asvg:svgBlip xmlns:asvg="http://schemas.microsoft.com/office/drawing/2016/SVG/main" r:embed="rId3"/>
+                <asvg:svgBlip xmlns:asvg="http://schemas.microsoft.com/office/drawing/2016/SVG/main" r:embed="rId2"/>
               </a:ext>
             </a:extLst>
           </a:blip>
@@ -10191,14 +10182,11 @@
                 <a:pPr/>
                 <a14:m>
                   <m:oMathPara xmlns:m="http://schemas.openxmlformats.org/officeDocument/2006/math">
-                    <m:oMathParaPr>
-                      <m:jc m:val="centerGroup"/>
-                    </m:oMathParaPr>
-                    <m:oMath xmlns:m="http://schemas.openxmlformats.org/officeDocument/2006/math">
+                    <m:oMath>
                       <m:sSub>
                         <m:sSubPr>
                           <m:ctrlPr>
-                            <a:rPr lang="de-DE" i="1" smtClean="0">
+                            <a:rPr lang="de-DE" b="0" i="1" smtClean="0">
                               <a:latin typeface="Cambria Math" panose="02040503050406030204" pitchFamily="18" charset="0"/>
                             </a:rPr>
                           </m:ctrlPr>
@@ -10266,14 +10254,11 @@
                 <a:pPr/>
                 <a14:m>
                   <m:oMathPara xmlns:m="http://schemas.openxmlformats.org/officeDocument/2006/math">
-                    <m:oMathParaPr>
-                      <m:jc m:val="centerGroup"/>
-                    </m:oMathParaPr>
-                    <m:oMath xmlns:m="http://schemas.openxmlformats.org/officeDocument/2006/math">
+                    <m:oMath>
                       <m:sSub>
                         <m:sSubPr>
                           <m:ctrlPr>
-                            <a:rPr lang="de-DE" i="1" smtClean="0">
+                            <a:rPr lang="de-DE" b="0" i="1" smtClean="0">
                               <a:latin typeface="Cambria Math" panose="02040503050406030204" pitchFamily="18" charset="0"/>
                             </a:rPr>
                           </m:ctrlPr>
@@ -10317,7 +10302,7 @@
                         <m:fPr>
                           <m:type m:val="lin"/>
                           <m:ctrlPr>
-                            <a:rPr lang="de-DE" b="0" i="1" smtClean="0">
+                            <a:rPr lang="de-DE" i="1">
                               <a:latin typeface="Cambria Math" panose="02040503050406030204" pitchFamily="18" charset="0"/>
                             </a:rPr>
                           </m:ctrlPr>
@@ -10356,7 +10341,7 @@
                           <m:sSub>
                             <m:sSubPr>
                               <m:ctrlPr>
-                                <a:rPr lang="de-DE" i="1">
+                                <a:rPr lang="de-DE" b="0" i="1" smtClean="0">
                                   <a:latin typeface="Cambria Math" panose="02040503050406030204" pitchFamily="18" charset="0"/>
                                 </a:rPr>
                               </m:ctrlPr>
@@ -10823,14 +10808,11 @@
                 <a:pPr/>
                 <a14:m>
                   <m:oMathPara xmlns:m="http://schemas.openxmlformats.org/officeDocument/2006/math">
-                    <m:oMathParaPr>
-                      <m:jc m:val="centerGroup"/>
-                    </m:oMathParaPr>
-                    <m:oMath xmlns:m="http://schemas.openxmlformats.org/officeDocument/2006/math">
+                    <m:oMath>
                       <m:sSub>
                         <m:sSubPr>
                           <m:ctrlPr>
-                            <a:rPr lang="de-DE" sz="2400" i="1" smtClean="0">
+                            <a:rPr lang="de-DE" sz="2400" b="0" i="1" smtClean="0">
                               <a:latin typeface="Cambria Math" panose="02040503050406030204" pitchFamily="18" charset="0"/>
                             </a:rPr>
                           </m:ctrlPr>
@@ -10861,7 +10843,7 @@
                       <m:sSub>
                         <m:sSubPr>
                           <m:ctrlPr>
-                            <a:rPr lang="de-DE" sz="2400" i="1" smtClean="0">
+                            <a:rPr lang="de-DE" sz="2400" b="0" i="1" smtClean="0">
                               <a:latin typeface="Cambria Math" panose="02040503050406030204" pitchFamily="18" charset="0"/>
                             </a:rPr>
                           </m:ctrlPr>
@@ -10923,7 +10905,7 @@
                       <m:sSub>
                         <m:sSubPr>
                           <m:ctrlPr>
-                            <a:rPr lang="de-DE" sz="2400" i="1" smtClean="0">
+                            <a:rPr lang="de-DE" sz="2400" i="1">
                               <a:latin typeface="Cambria Math" panose="02040503050406030204" pitchFamily="18" charset="0"/>
                             </a:rPr>
                           </m:ctrlPr>
@@ -11028,14 +11010,11 @@
                 <a:pPr/>
                 <a14:m>
                   <m:oMathPara xmlns:m="http://schemas.openxmlformats.org/officeDocument/2006/math">
-                    <m:oMathParaPr>
-                      <m:jc m:val="centerGroup"/>
-                    </m:oMathParaPr>
-                    <m:oMath xmlns:m="http://schemas.openxmlformats.org/officeDocument/2006/math">
+                    <m:oMath>
                       <m:sSub>
                         <m:sSubPr>
                           <m:ctrlPr>
-                            <a:rPr lang="de-DE" sz="2400" i="1">
+                            <a:rPr lang="de-DE" sz="2400" b="0" i="1" smtClean="0">
                               <a:latin typeface="Cambria Math" panose="02040503050406030204" pitchFamily="18" charset="0"/>
                             </a:rPr>
                           </m:ctrlPr>
@@ -11066,7 +11045,7 @@
                       <m:sSub>
                         <m:sSubPr>
                           <m:ctrlPr>
-                            <a:rPr lang="de-DE" sz="2400" i="1">
+                            <a:rPr lang="de-DE" sz="2400" b="0" i="1" smtClean="0">
                               <a:latin typeface="Cambria Math" panose="02040503050406030204" pitchFamily="18" charset="0"/>
                             </a:rPr>
                           </m:ctrlPr>
@@ -11140,14 +11119,11 @@
                 <a:pPr/>
                 <a14:m>
                   <m:oMathPara xmlns:m="http://schemas.openxmlformats.org/officeDocument/2006/math">
-                    <m:oMathParaPr>
-                      <m:jc m:val="centerGroup"/>
-                    </m:oMathParaPr>
-                    <m:oMath xmlns:m="http://schemas.openxmlformats.org/officeDocument/2006/math">
+                    <m:oMath>
                       <m:sSub>
                         <m:sSubPr>
                           <m:ctrlPr>
-                            <a:rPr lang="de-DE" sz="2400" i="1">
+                            <a:rPr lang="de-DE" sz="2400" i="1" smtClean="0">
                               <a:latin typeface="Cambria Math" panose="02040503050406030204" pitchFamily="18" charset="0"/>
                             </a:rPr>
                           </m:ctrlPr>
@@ -11156,7 +11132,7 @@
                           <m:sSub>
                             <m:sSubPr>
                               <m:ctrlPr>
-                                <a:rPr lang="de-DE" sz="2400" i="1" smtClean="0">
+                                <a:rPr lang="de-DE" sz="2400" b="0" i="1" smtClean="0">
                                   <a:latin typeface="Cambria Math" panose="02040503050406030204" pitchFamily="18" charset="0"/>
                                 </a:rPr>
                               </m:ctrlPr>
@@ -11240,10 +11216,7 @@
                 <a:pPr/>
                 <a14:m>
                   <m:oMathPara xmlns:m="http://schemas.openxmlformats.org/officeDocument/2006/math">
-                    <m:oMathParaPr>
-                      <m:jc m:val="centerGroup"/>
-                    </m:oMathParaPr>
-                    <m:oMath xmlns:m="http://schemas.openxmlformats.org/officeDocument/2006/math">
+                    <m:oMath>
                       <m:r>
                         <a:rPr lang="de-DE" sz="2400" b="0" i="1" smtClean="0">
                           <a:latin typeface="Cambria Math" panose="02040503050406030204" pitchFamily="18" charset="0"/>
@@ -12092,7 +12065,7 @@
                     <m:sSub>
                       <m:sSubPr>
                         <m:ctrlPr>
-                          <a:rPr lang="de-DE" sz="2600" i="1" smtClean="0">
+                          <a:rPr lang="de-DE" sz="2600" b="0" i="1" smtClean="0">
                             <a:latin typeface="Cambria Math" panose="02040503050406030204" pitchFamily="18" charset="0"/>
                           </a:rPr>
                         </m:ctrlPr>
@@ -12823,7 +12796,7 @@
                     <m:sSub>
                       <m:sSubPr>
                         <m:ctrlPr>
-                          <a:rPr lang="de-DE" sz="2600" i="1" smtClean="0">
+                          <a:rPr lang="de-DE" sz="2600" b="0" i="1" smtClean="0">
                             <a:latin typeface="Cambria Math" panose="02040503050406030204" pitchFamily="18" charset="0"/>
                           </a:rPr>
                         </m:ctrlPr>
@@ -13461,10 +13434,10 @@
           <p:nvPr/>
         </p:nvPicPr>
         <p:blipFill>
-          <a:blip r:embed="rId4">
+          <a:blip>
             <a:extLst>
               <a:ext uri="{96DAC541-7B7A-43D3-8B79-37D633B846F1}">
-                <asvg:svgBlip xmlns:asvg="http://schemas.microsoft.com/office/drawing/2016/SVG/main" r:embed="rId5"/>
+                <asvg:svgBlip xmlns:asvg="http://schemas.microsoft.com/office/drawing/2016/SVG/main" r:embed="rId4"/>
               </a:ext>
             </a:extLst>
           </a:blip>
@@ -13644,7 +13617,7 @@
                     <m:sSub>
                       <m:sSubPr>
                         <m:ctrlPr>
-                          <a:rPr lang="de-DE" i="1" smtClean="0">
+                          <a:rPr lang="de-DE" b="0" i="0" smtClean="0">
                             <a:latin typeface="Cambria Math" panose="02040503050406030204" pitchFamily="18" charset="0"/>
                           </a:rPr>
                         </m:ctrlPr>
@@ -13680,7 +13653,7 @@
                     <m:sSub>
                       <m:sSubPr>
                         <m:ctrlPr>
-                          <a:rPr lang="de-DE" i="1">
+                          <a:rPr lang="de-DE">
                             <a:latin typeface="Cambria Math" panose="02040503050406030204" pitchFamily="18" charset="0"/>
                           </a:rPr>
                         </m:ctrlPr>
@@ -13716,14 +13689,11 @@
                 <a:pPr/>
                 <a14:m>
                   <m:oMathPara xmlns:m="http://schemas.openxmlformats.org/officeDocument/2006/math">
-                    <m:oMathParaPr>
-                      <m:jc m:val="centerGroup"/>
-                    </m:oMathParaPr>
-                    <m:oMath xmlns:m="http://schemas.openxmlformats.org/officeDocument/2006/math">
+                    <m:oMath>
                       <m:sSub>
                         <m:sSubPr>
                           <m:ctrlPr>
-                            <a:rPr lang="de-DE" i="1" smtClean="0">
+                            <a:rPr lang="de-DE" b="0" i="1" smtClean="0">
                               <a:latin typeface="Cambria Math" panose="02040503050406030204" pitchFamily="18" charset="0"/>
                             </a:rPr>
                           </m:ctrlPr>
@@ -19554,14 +19524,11 @@
                 </a:pPr>
                 <a14:m>
                   <m:oMathPara xmlns:m="http://schemas.openxmlformats.org/officeDocument/2006/math">
-                    <m:oMathParaPr>
-                      <m:jc m:val="centerGroup"/>
-                    </m:oMathParaPr>
-                    <m:oMath xmlns:m="http://schemas.openxmlformats.org/officeDocument/2006/math">
+                    <m:oMath>
                       <m:sSub>
                         <m:sSubPr>
                           <m:ctrlPr>
-                            <a:rPr lang="de-DE" sz="1800" i="1" smtClean="0">
+                            <a:rPr lang="de-DE" sz="1800" i="1">
                               <a:latin typeface="Cambria Math" panose="02040503050406030204" pitchFamily="18" charset="0"/>
                             </a:rPr>
                           </m:ctrlPr>
@@ -19668,10 +19635,7 @@
                 </a:pPr>
                 <a14:m>
                   <m:oMathPara xmlns:m="http://schemas.openxmlformats.org/officeDocument/2006/math">
-                    <m:oMathParaPr>
-                      <m:jc m:val="centerGroup"/>
-                    </m:oMathParaPr>
-                    <m:oMath xmlns:m="http://schemas.openxmlformats.org/officeDocument/2006/math">
+                    <m:oMath>
                       <m:r>
                         <a:rPr lang="de-DE" sz="1800" i="1">
                           <a:latin typeface="Cambria Math" panose="02040503050406030204" pitchFamily="18" charset="0"/>
@@ -19788,10 +19752,7 @@
                 </a:pPr>
                 <a14:m>
                   <m:oMathPara xmlns:m="http://schemas.openxmlformats.org/officeDocument/2006/math">
-                    <m:oMathParaPr>
-                      <m:jc m:val="centerGroup"/>
-                    </m:oMathParaPr>
-                    <m:oMath xmlns:m="http://schemas.openxmlformats.org/officeDocument/2006/math">
+                    <m:oMath>
                       <m:sSub>
                         <m:sSubPr>
                           <m:ctrlPr>
@@ -19902,10 +19863,7 @@
                 </a:pPr>
                 <a14:m>
                   <m:oMathPara xmlns:m="http://schemas.openxmlformats.org/officeDocument/2006/math">
-                    <m:oMathParaPr>
-                      <m:jc m:val="centerGroup"/>
-                    </m:oMathParaPr>
-                    <m:oMath xmlns:m="http://schemas.openxmlformats.org/officeDocument/2006/math">
+                    <m:oMath>
                       <m:sSub>
                         <m:sSubPr>
                           <m:ctrlPr>
@@ -20170,10 +20128,7 @@
                 <a:pPr/>
                 <a14:m>
                   <m:oMathPara xmlns:m="http://schemas.openxmlformats.org/officeDocument/2006/math">
-                    <m:oMathParaPr>
-                      <m:jc m:val="centerGroup"/>
-                    </m:oMathParaPr>
-                    <m:oMath xmlns:m="http://schemas.openxmlformats.org/officeDocument/2006/math">
+                    <m:oMath>
                       <m:sSub>
                         <m:sSubPr>
                           <m:ctrlPr>
@@ -20438,10 +20393,7 @@
                 <a:pPr/>
                 <a14:m>
                   <m:oMathPara xmlns:m="http://schemas.openxmlformats.org/officeDocument/2006/math">
-                    <m:oMathParaPr>
-                      <m:jc m:val="centerGroup"/>
-                    </m:oMathParaPr>
-                    <m:oMath xmlns:m="http://schemas.openxmlformats.org/officeDocument/2006/math">
+                    <m:oMath>
                       <m:sSub>
                         <m:sSubPr>
                           <m:ctrlPr>
@@ -21066,8 +21018,8 @@
           <a:chExt cx="0" cy="0"/>
         </a:xfrm>
       </p:grpSpPr>
-      <mc:AlternateContent xmlns:mc="http://schemas.openxmlformats.org/markup-compatibility/2006">
-        <mc:Choice xmlns:a14="http://schemas.microsoft.com/office/drawing/2010/main" Requires="a14">
+      <mc:AlternateContent xmlns:mc="http://schemas.openxmlformats.org/markup-compatibility/2006" xmlns:a14="http://schemas.microsoft.com/office/drawing/2010/main">
+        <mc:Choice Requires="a14">
           <p:sp>
             <p:nvSpPr>
               <p:cNvPr id="4" name="Inhaltsplatzhalter 3">
@@ -21397,7 +21349,7 @@
             </p:txBody>
           </p:sp>
         </mc:Choice>
-        <mc:Fallback>
+        <mc:Fallback xmlns="">
           <p:sp>
             <p:nvSpPr>
               <p:cNvPr id="4" name="Inhaltsplatzhalter 3">
@@ -21441,8 +21393,8 @@
           </p:sp>
         </mc:Fallback>
       </mc:AlternateContent>
-      <mc:AlternateContent xmlns:mc="http://schemas.openxmlformats.org/markup-compatibility/2006">
-        <mc:Choice xmlns:a14="http://schemas.microsoft.com/office/drawing/2010/main" Requires="a14">
+      <mc:AlternateContent xmlns:mc="http://schemas.openxmlformats.org/markup-compatibility/2006" xmlns:a14="http://schemas.microsoft.com/office/drawing/2010/main">
+        <mc:Choice Requires="a14">
           <p:sp>
             <p:nvSpPr>
               <p:cNvPr id="27" name="Textfeld 26">
@@ -21485,7 +21437,7 @@
                     <m:sSub>
                       <m:sSubPr>
                         <m:ctrlPr>
-                          <a:rPr lang="de-DE" i="1" smtClean="0">
+                          <a:rPr lang="de-DE" b="0" i="1" smtClean="0">
                             <a:latin typeface="Cambria Math" panose="02040503050406030204" pitchFamily="18" charset="0"/>
                           </a:rPr>
                         </m:ctrlPr>
@@ -21611,7 +21563,7 @@
                     <m:sSub>
                       <m:sSubPr>
                         <m:ctrlPr>
-                          <a:rPr lang="de-DE" i="1" smtClean="0">
+                          <a:rPr lang="de-DE" b="0" i="1" smtClean="0">
                             <a:latin typeface="Cambria Math" panose="02040503050406030204" pitchFamily="18" charset="0"/>
                           </a:rPr>
                         </m:ctrlPr>
@@ -21702,7 +21654,7 @@
             </p:txBody>
           </p:sp>
         </mc:Choice>
-        <mc:Fallback>
+        <mc:Fallback xmlns="">
           <p:sp>
             <p:nvSpPr>
               <p:cNvPr id="27" name="Textfeld 26">
@@ -21973,8 +21925,8 @@
           </a:fontRef>
         </p:style>
       </p:cxnSp>
-      <mc:AlternateContent xmlns:mc="http://schemas.openxmlformats.org/markup-compatibility/2006">
-        <mc:Choice xmlns:a14="http://schemas.microsoft.com/office/drawing/2010/main" Requires="a14">
+      <mc:AlternateContent xmlns:mc="http://schemas.openxmlformats.org/markup-compatibility/2006" xmlns:a14="http://schemas.microsoft.com/office/drawing/2010/main">
+        <mc:Choice Requires="a14">
           <p:sp>
             <p:nvSpPr>
               <p:cNvPr id="28" name="Textfeld 27">
@@ -22017,7 +21969,7 @@
                     <m:sSub>
                       <m:sSubPr>
                         <m:ctrlPr>
-                          <a:rPr lang="de-DE" i="1" smtClean="0">
+                          <a:rPr lang="de-DE" b="0" i="1" smtClean="0">
                             <a:latin typeface="Cambria Math" panose="02040503050406030204" pitchFamily="18" charset="0"/>
                           </a:rPr>
                         </m:ctrlPr>
@@ -22196,7 +22148,7 @@
                         <m:sSub>
                           <m:sSubPr>
                             <m:ctrlPr>
-                              <a:rPr lang="de-DE" i="1" smtClean="0">
+                              <a:rPr lang="de-DE" b="0" i="1" smtClean="0">
                                 <a:latin typeface="Cambria Math" panose="02040503050406030204" pitchFamily="18" charset="0"/>
                               </a:rPr>
                             </m:ctrlPr>
@@ -22362,7 +22314,7 @@
             </p:txBody>
           </p:sp>
         </mc:Choice>
-        <mc:Fallback>
+        <mc:Fallback xmlns="">
           <p:sp>
             <p:nvSpPr>
               <p:cNvPr id="28" name="Textfeld 27">
@@ -22412,8 +22364,8 @@
           </p:sp>
         </mc:Fallback>
       </mc:AlternateContent>
-      <mc:AlternateContent xmlns:mc="http://schemas.openxmlformats.org/markup-compatibility/2006">
-        <mc:Choice xmlns:a14="http://schemas.microsoft.com/office/drawing/2010/main" Requires="a14">
+      <mc:AlternateContent xmlns:mc="http://schemas.openxmlformats.org/markup-compatibility/2006" xmlns:a14="http://schemas.microsoft.com/office/drawing/2010/main">
+        <mc:Choice Requires="a14">
           <p:sp>
             <p:nvSpPr>
               <p:cNvPr id="5" name="Textfeld 4">
@@ -22445,12 +22397,10 @@
               </a:bodyPr>
               <a:lstStyle/>
               <a:p>
+                <a:pPr/>
                 <a14:m>
                   <m:oMathPara xmlns:m="http://schemas.openxmlformats.org/officeDocument/2006/math">
-                    <m:oMathParaPr>
-                      <m:jc m:val="centerGroup"/>
-                    </m:oMathParaPr>
-                    <m:oMath xmlns:m="http://schemas.openxmlformats.org/officeDocument/2006/math">
+                    <m:oMath>
                       <m:r>
                         <a:rPr lang="de-DE" sz="2400" b="0" i="1" smtClean="0">
                           <a:latin typeface="Cambria Math" panose="02040503050406030204" pitchFamily="18" charset="0"/>
@@ -22552,7 +22502,7 @@
             </p:txBody>
           </p:sp>
         </mc:Choice>
-        <mc:Fallback>
+        <mc:Fallback xmlns="">
           <p:sp>
             <p:nvSpPr>
               <p:cNvPr id="5" name="Textfeld 4">
@@ -22702,10 +22652,7 @@
                 </a:pPr>
                 <a14:m>
                   <m:oMathPara xmlns:m="http://schemas.openxmlformats.org/officeDocument/2006/math">
-                    <m:oMathParaPr>
-                      <m:jc m:val="centerGroup"/>
-                    </m:oMathParaPr>
-                    <m:oMath xmlns:m="http://schemas.openxmlformats.org/officeDocument/2006/math">
+                    <m:oMath>
                       <m:r>
                         <a:rPr lang="de-DE" sz="3400" i="1" smtClean="0">
                           <a:latin typeface="Cambria Math" panose="02040503050406030204" pitchFamily="18" charset="0"/>
@@ -23610,10 +23557,7 @@
                 </a:pPr>
                 <a14:m>
                   <m:oMathPara xmlns:m="http://schemas.openxmlformats.org/officeDocument/2006/math">
-                    <m:oMathParaPr>
-                      <m:jc m:val="centerGroup"/>
-                    </m:oMathParaPr>
-                    <m:oMath xmlns:m="http://schemas.openxmlformats.org/officeDocument/2006/math">
+                    <m:oMath>
                       <m:sSub>
                         <m:sSubPr>
                           <m:ctrlPr>
@@ -23856,10 +23800,7 @@
                 </a:pPr>
                 <a14:m>
                   <m:oMathPara xmlns:m="http://schemas.openxmlformats.org/officeDocument/2006/math">
-                    <m:oMathParaPr>
-                      <m:jc m:val="centerGroup"/>
-                    </m:oMathParaPr>
-                    <m:oMath xmlns:m="http://schemas.openxmlformats.org/officeDocument/2006/math">
+                    <m:oMath>
                       <m:r>
                         <a:rPr lang="de-DE" sz="2400" i="1">
                           <a:latin typeface="Cambria Math" panose="02040503050406030204" pitchFamily="18" charset="0"/>
@@ -24407,10 +24348,7 @@
                 </a:pPr>
                 <a14:m>
                   <m:oMathPara xmlns:m="http://schemas.openxmlformats.org/officeDocument/2006/math">
-                    <m:oMathParaPr>
-                      <m:jc m:val="centerGroup"/>
-                    </m:oMathParaPr>
-                    <m:oMath xmlns:m="http://schemas.openxmlformats.org/officeDocument/2006/math">
+                    <m:oMath>
                       <m:f>
                         <m:fPr>
                           <m:ctrlPr>
@@ -25678,7 +25616,7 @@
                     <m:sSub>
                       <m:sSubPr>
                         <m:ctrlPr>
-                          <a:rPr lang="de-DE" sz="2200" i="1" smtClean="0">
+                          <a:rPr lang="de-DE" sz="2200" b="0" i="1" smtClean="0">
                             <a:latin typeface="Cambria Math" panose="02040503050406030204" pitchFamily="18" charset="0"/>
                           </a:rPr>
                         </m:ctrlPr>
@@ -26372,7 +26310,7 @@
                     <m:sSub>
                       <m:sSubPr>
                         <m:ctrlPr>
-                          <a:rPr lang="de-DE" sz="2400" i="1" smtClean="0">
+                          <a:rPr lang="de-DE" sz="2400" b="0" i="1" smtClean="0">
                             <a:latin typeface="Cambria Math" panose="02040503050406030204" pitchFamily="18" charset="0"/>
                           </a:rPr>
                         </m:ctrlPr>
@@ -26945,10 +26883,10 @@
           <p:nvPr/>
         </p:nvPicPr>
         <p:blipFill>
-          <a:blip r:embed="rId2">
+          <a:blip>
             <a:extLst>
               <a:ext uri="{96DAC541-7B7A-43D3-8B79-37D633B846F1}">
-                <asvg:svgBlip xmlns:asvg="http://schemas.microsoft.com/office/drawing/2016/SVG/main" r:embed="rId3"/>
+                <asvg:svgBlip xmlns:asvg="http://schemas.microsoft.com/office/drawing/2016/SVG/main" r:embed="rId2"/>
               </a:ext>
             </a:extLst>
           </a:blip>
@@ -26999,10 +26937,7 @@
                 <a:pPr/>
                 <a14:m>
                   <m:oMathPara xmlns:m="http://schemas.openxmlformats.org/officeDocument/2006/math">
-                    <m:oMathParaPr>
-                      <m:jc m:val="centerGroup"/>
-                    </m:oMathParaPr>
-                    <m:oMath xmlns:m="http://schemas.openxmlformats.org/officeDocument/2006/math">
+                    <m:oMath>
                       <m:r>
                         <a:rPr lang="de-DE" sz="2800" b="0" i="1" smtClean="0">
                           <a:solidFill>
@@ -28078,10 +28013,10 @@
           <p:nvPr/>
         </p:nvPicPr>
         <p:blipFill>
-          <a:blip r:embed="rId2">
+          <a:blip>
             <a:extLst>
               <a:ext uri="{96DAC541-7B7A-43D3-8B79-37D633B846F1}">
-                <asvg:svgBlip xmlns:asvg="http://schemas.microsoft.com/office/drawing/2016/SVG/main" r:embed="rId3"/>
+                <asvg:svgBlip xmlns:asvg="http://schemas.microsoft.com/office/drawing/2016/SVG/main" r:embed="rId2"/>
               </a:ext>
             </a:extLst>
           </a:blip>
@@ -28648,10 +28583,10 @@
           <p:nvPr/>
         </p:nvPicPr>
         <p:blipFill>
-          <a:blip r:embed="rId2">
+          <a:blip>
             <a:extLst>
               <a:ext uri="{96DAC541-7B7A-43D3-8B79-37D633B846F1}">
-                <asvg:svgBlip xmlns:asvg="http://schemas.microsoft.com/office/drawing/2016/SVG/main" r:embed="rId3"/>
+                <asvg:svgBlip xmlns:asvg="http://schemas.microsoft.com/office/drawing/2016/SVG/main" r:embed="rId2"/>
               </a:ext>
             </a:extLst>
           </a:blip>
@@ -29578,10 +29513,10 @@
           <p:nvPr/>
         </p:nvPicPr>
         <p:blipFill>
-          <a:blip r:embed="rId4">
+          <a:blip>
             <a:extLst>
               <a:ext uri="{96DAC541-7B7A-43D3-8B79-37D633B846F1}">
-                <asvg:svgBlip xmlns:asvg="http://schemas.microsoft.com/office/drawing/2016/SVG/main" r:embed="rId5"/>
+                <asvg:svgBlip xmlns:asvg="http://schemas.microsoft.com/office/drawing/2016/SVG/main" r:embed="rId4"/>
               </a:ext>
             </a:extLst>
           </a:blip>
@@ -29614,10 +29549,10 @@
           <p:nvPr/>
         </p:nvPicPr>
         <p:blipFill>
-          <a:blip r:embed="rId6">
+          <a:blip>
             <a:extLst>
               <a:ext uri="{96DAC541-7B7A-43D3-8B79-37D633B846F1}">
-                <asvg:svgBlip xmlns:asvg="http://schemas.microsoft.com/office/drawing/2016/SVG/main" r:embed="rId7"/>
+                <asvg:svgBlip xmlns:asvg="http://schemas.microsoft.com/office/drawing/2016/SVG/main" r:embed="rId5"/>
               </a:ext>
             </a:extLst>
           </a:blip>

</xml_diff>